<commit_message>
fix(presentation): remove crop and rescale figures to native aspect
All 10 pictures in Zannat's deck (and 1 in ours) had been forced into
wrong-aspect slots via srcRect cropping, chopping up to 25% off the
top and bottom of each figure. Most affected: ROC/PR curves (slide 8),
domain heatmap (slide 9), LR coefficients and LightGBM importance
(slide 11) — each lost ~45-48% of vertical content.

Removed all crop directives and rescaled each picture to its native
aspect ratio, recentered within its original slot. Full content of
every figure is now visible without distortion.

Co-authored-by: Cursor <cursoragent@cursor.com>
</commit_message>
<xml_diff>
--- a/presentation/ELSA_Depression_Prediction.pptx
+++ b/presentation/ELSA_Depression_Prediction.pptx
@@ -5,22 +5,22 @@
     <p:sldMasterId id="2147483648" r:id="rId1"/>
   </p:sldMasterIdLst>
   <p:sldIdLst>
-    <p:sldId id="256" r:id="rId7"/>
-    <p:sldId id="257" r:id="rId8"/>
-    <p:sldId id="258" r:id="rId9"/>
-    <p:sldId id="259" r:id="rId10"/>
-    <p:sldId id="260" r:id="rId11"/>
-    <p:sldId id="261" r:id="rId12"/>
-    <p:sldId id="262" r:id="rId13"/>
-    <p:sldId id="263" r:id="rId14"/>
-    <p:sldId id="264" r:id="rId15"/>
-    <p:sldId id="265" r:id="rId16"/>
-    <p:sldId id="266" r:id="rId17"/>
-    <p:sldId id="267" r:id="rId18"/>
-    <p:sldId id="268" r:id="rId19"/>
-    <p:sldId id="269" r:id="rId20"/>
+    <p:sldId id="256" r:id="rId2"/>
+    <p:sldId id="257" r:id="rId3"/>
+    <p:sldId id="258" r:id="rId4"/>
+    <p:sldId id="259" r:id="rId5"/>
+    <p:sldId id="260" r:id="rId6"/>
+    <p:sldId id="261" r:id="rId7"/>
+    <p:sldId id="262" r:id="rId8"/>
+    <p:sldId id="263" r:id="rId9"/>
+    <p:sldId id="264" r:id="rId10"/>
+    <p:sldId id="265" r:id="rId11"/>
+    <p:sldId id="266" r:id="rId12"/>
+    <p:sldId id="267" r:id="rId13"/>
+    <p:sldId id="268" r:id="rId14"/>
+    <p:sldId id="269" r:id="rId15"/>
   </p:sldIdLst>
-  <p:sldSz cx="12191695" cy="6858000" type="screen4x3"/>
+  <p:sldSz cx="12192000" cy="6858000"/>
   <p:notesSz cx="6858000" cy="9144000"/>
   <p:defaultTextStyle>
     <a:defPPr>
@@ -117,6 +117,22 @@
       </a:defRPr>
     </a:lvl9pPr>
   </p:defaultTextStyle>
+  <p:extLst>
+    <p:ext uri="{EFAFB233-063F-42B5-8137-9DF3F51BA10A}">
+      <p15:sldGuideLst xmlns:p15="http://schemas.microsoft.com/office/powerpoint/2012/main">
+        <p15:guide id="1" orient="horz" pos="2160">
+          <p15:clr>
+            <a:srgbClr val="A4A3A4"/>
+          </p15:clr>
+        </p15:guide>
+        <p15:guide id="2" pos="2880">
+          <p15:clr>
+            <a:srgbClr val="A4A3A4"/>
+          </p15:clr>
+        </p15:guide>
+      </p15:sldGuideLst>
+    </p:ext>
+  </p:extLst>
 </p:presentation>
 </file>
 
@@ -158,10 +174,9 @@
           <a:lstStyle/>
           <a:p>
             <a:r>
-              <a:rPr lang="en-US" smtClean="0"/>
+              <a:rPr lang="en-US"/>
               <a:t>Click to edit Master title style</a:t>
             </a:r>
-            <a:endParaRPr lang="en-US"/>
           </a:p>
         </p:txBody>
       </p:sp>
@@ -277,10 +292,9 @@
           </a:lstStyle>
           <a:p>
             <a:r>
-              <a:rPr lang="en-US" smtClean="0"/>
+              <a:rPr lang="en-US"/>
               <a:t>Click to edit Master subtitle style</a:t>
             </a:r>
-            <a:endParaRPr lang="en-US"/>
           </a:p>
         </p:txBody>
       </p:sp>
@@ -301,7 +315,7 @@
           <a:p>
             <a:fld id="{5BCAD085-E8A6-8845-BD4E-CB4CCA059FC4}" type="datetimeFigureOut">
               <a:rPr lang="en-US" smtClean="0"/>
-              <a:t>1/27/13</a:t>
+              <a:t>5/5/26</a:t>
             </a:fld>
             <a:endParaRPr lang="en-US"/>
           </a:p>
@@ -395,10 +409,9 @@
           <a:lstStyle/>
           <a:p>
             <a:r>
-              <a:rPr lang="en-US" smtClean="0"/>
+              <a:rPr lang="en-US"/>
               <a:t>Click to edit Master title style</a:t>
             </a:r>
-            <a:endParaRPr lang="en-US"/>
           </a:p>
         </p:txBody>
       </p:sp>
@@ -419,38 +432,37 @@
           <a:p>
             <a:pPr lvl="0"/>
             <a:r>
-              <a:rPr lang="en-US" smtClean="0"/>
+              <a:rPr lang="en-US"/>
               <a:t>Click to edit Master text styles</a:t>
             </a:r>
           </a:p>
           <a:p>
             <a:pPr lvl="1"/>
             <a:r>
-              <a:rPr lang="en-US" smtClean="0"/>
+              <a:rPr lang="en-US"/>
               <a:t>Second level</a:t>
             </a:r>
           </a:p>
           <a:p>
             <a:pPr lvl="2"/>
             <a:r>
-              <a:rPr lang="en-US" smtClean="0"/>
+              <a:rPr lang="en-US"/>
               <a:t>Third level</a:t>
             </a:r>
           </a:p>
           <a:p>
             <a:pPr lvl="3"/>
             <a:r>
-              <a:rPr lang="en-US" smtClean="0"/>
+              <a:rPr lang="en-US"/>
               <a:t>Fourth level</a:t>
             </a:r>
           </a:p>
           <a:p>
             <a:pPr lvl="4"/>
             <a:r>
-              <a:rPr lang="en-US" smtClean="0"/>
+              <a:rPr lang="en-US"/>
               <a:t>Fifth level</a:t>
             </a:r>
-            <a:endParaRPr lang="en-US"/>
           </a:p>
         </p:txBody>
       </p:sp>
@@ -471,7 +483,7 @@
           <a:p>
             <a:fld id="{5BCAD085-E8A6-8845-BD4E-CB4CCA059FC4}" type="datetimeFigureOut">
               <a:rPr lang="en-US" smtClean="0"/>
-              <a:t>1/27/13</a:t>
+              <a:t>5/5/26</a:t>
             </a:fld>
             <a:endParaRPr lang="en-US"/>
           </a:p>
@@ -570,10 +582,9 @@
           <a:lstStyle/>
           <a:p>
             <a:r>
-              <a:rPr lang="en-US" smtClean="0"/>
+              <a:rPr lang="en-US"/>
               <a:t>Click to edit Master title style</a:t>
             </a:r>
-            <a:endParaRPr lang="en-US"/>
           </a:p>
         </p:txBody>
       </p:sp>
@@ -599,38 +610,37 @@
           <a:p>
             <a:pPr lvl="0"/>
             <a:r>
-              <a:rPr lang="en-US" smtClean="0"/>
+              <a:rPr lang="en-US"/>
               <a:t>Click to edit Master text styles</a:t>
             </a:r>
           </a:p>
           <a:p>
             <a:pPr lvl="1"/>
             <a:r>
-              <a:rPr lang="en-US" smtClean="0"/>
+              <a:rPr lang="en-US"/>
               <a:t>Second level</a:t>
             </a:r>
           </a:p>
           <a:p>
             <a:pPr lvl="2"/>
             <a:r>
-              <a:rPr lang="en-US" smtClean="0"/>
+              <a:rPr lang="en-US"/>
               <a:t>Third level</a:t>
             </a:r>
           </a:p>
           <a:p>
             <a:pPr lvl="3"/>
             <a:r>
-              <a:rPr lang="en-US" smtClean="0"/>
+              <a:rPr lang="en-US"/>
               <a:t>Fourth level</a:t>
             </a:r>
           </a:p>
           <a:p>
             <a:pPr lvl="4"/>
             <a:r>
-              <a:rPr lang="en-US" smtClean="0"/>
+              <a:rPr lang="en-US"/>
               <a:t>Fifth level</a:t>
             </a:r>
-            <a:endParaRPr lang="en-US"/>
           </a:p>
         </p:txBody>
       </p:sp>
@@ -651,7 +661,7 @@
           <a:p>
             <a:fld id="{5BCAD085-E8A6-8845-BD4E-CB4CCA059FC4}" type="datetimeFigureOut">
               <a:rPr lang="en-US" smtClean="0"/>
-              <a:t>1/27/13</a:t>
+              <a:t>5/5/26</a:t>
             </a:fld>
             <a:endParaRPr lang="en-US"/>
           </a:p>
@@ -745,10 +755,9 @@
           <a:lstStyle/>
           <a:p>
             <a:r>
-              <a:rPr lang="en-US" smtClean="0"/>
+              <a:rPr lang="en-US"/>
               <a:t>Click to edit Master title style</a:t>
             </a:r>
-            <a:endParaRPr lang="en-US"/>
           </a:p>
         </p:txBody>
       </p:sp>
@@ -769,38 +778,37 @@
           <a:p>
             <a:pPr lvl="0"/>
             <a:r>
-              <a:rPr lang="en-US" smtClean="0"/>
+              <a:rPr lang="en-US"/>
               <a:t>Click to edit Master text styles</a:t>
             </a:r>
           </a:p>
           <a:p>
             <a:pPr lvl="1"/>
             <a:r>
-              <a:rPr lang="en-US" smtClean="0"/>
+              <a:rPr lang="en-US"/>
               <a:t>Second level</a:t>
             </a:r>
           </a:p>
           <a:p>
             <a:pPr lvl="2"/>
             <a:r>
-              <a:rPr lang="en-US" smtClean="0"/>
+              <a:rPr lang="en-US"/>
               <a:t>Third level</a:t>
             </a:r>
           </a:p>
           <a:p>
             <a:pPr lvl="3"/>
             <a:r>
-              <a:rPr lang="en-US" smtClean="0"/>
+              <a:rPr lang="en-US"/>
               <a:t>Fourth level</a:t>
             </a:r>
           </a:p>
           <a:p>
             <a:pPr lvl="4"/>
             <a:r>
-              <a:rPr lang="en-US" smtClean="0"/>
+              <a:rPr lang="en-US"/>
               <a:t>Fifth level</a:t>
             </a:r>
-            <a:endParaRPr lang="en-US"/>
           </a:p>
         </p:txBody>
       </p:sp>
@@ -821,7 +829,7 @@
           <a:p>
             <a:fld id="{5BCAD085-E8A6-8845-BD4E-CB4CCA059FC4}" type="datetimeFigureOut">
               <a:rPr lang="en-US" smtClean="0"/>
-              <a:t>1/27/13</a:t>
+              <a:t>5/5/26</a:t>
             </a:fld>
             <a:endParaRPr lang="en-US"/>
           </a:p>
@@ -924,10 +932,9 @@
           </a:lstStyle>
           <a:p>
             <a:r>
-              <a:rPr lang="en-US" smtClean="0"/>
+              <a:rPr lang="en-US"/>
               <a:t>Click to edit Master title style</a:t>
             </a:r>
-            <a:endParaRPr lang="en-US"/>
           </a:p>
         </p:txBody>
       </p:sp>
@@ -1044,7 +1051,7 @@
           <a:p>
             <a:pPr lvl="0"/>
             <a:r>
-              <a:rPr lang="en-US" smtClean="0"/>
+              <a:rPr lang="en-US"/>
               <a:t>Click to edit Master text styles</a:t>
             </a:r>
           </a:p>
@@ -1067,7 +1074,7 @@
           <a:p>
             <a:fld id="{5BCAD085-E8A6-8845-BD4E-CB4CCA059FC4}" type="datetimeFigureOut">
               <a:rPr lang="en-US" smtClean="0"/>
-              <a:t>1/27/13</a:t>
+              <a:t>5/5/26</a:t>
             </a:fld>
             <a:endParaRPr lang="en-US"/>
           </a:p>
@@ -1161,10 +1168,9 @@
           <a:lstStyle/>
           <a:p>
             <a:r>
-              <a:rPr lang="en-US" smtClean="0"/>
+              <a:rPr lang="en-US"/>
               <a:t>Click to edit Master title style</a:t>
             </a:r>
-            <a:endParaRPr lang="en-US"/>
           </a:p>
         </p:txBody>
       </p:sp>
@@ -1218,38 +1224,37 @@
           <a:p>
             <a:pPr lvl="0"/>
             <a:r>
-              <a:rPr lang="en-US" smtClean="0"/>
+              <a:rPr lang="en-US"/>
               <a:t>Click to edit Master text styles</a:t>
             </a:r>
           </a:p>
           <a:p>
             <a:pPr lvl="1"/>
             <a:r>
-              <a:rPr lang="en-US" smtClean="0"/>
+              <a:rPr lang="en-US"/>
               <a:t>Second level</a:t>
             </a:r>
           </a:p>
           <a:p>
             <a:pPr lvl="2"/>
             <a:r>
-              <a:rPr lang="en-US" smtClean="0"/>
+              <a:rPr lang="en-US"/>
               <a:t>Third level</a:t>
             </a:r>
           </a:p>
           <a:p>
             <a:pPr lvl="3"/>
             <a:r>
-              <a:rPr lang="en-US" smtClean="0"/>
+              <a:rPr lang="en-US"/>
               <a:t>Fourth level</a:t>
             </a:r>
           </a:p>
           <a:p>
             <a:pPr lvl="4"/>
             <a:r>
-              <a:rPr lang="en-US" smtClean="0"/>
+              <a:rPr lang="en-US"/>
               <a:t>Fifth level</a:t>
             </a:r>
-            <a:endParaRPr lang="en-US"/>
           </a:p>
         </p:txBody>
       </p:sp>
@@ -1303,38 +1308,37 @@
           <a:p>
             <a:pPr lvl="0"/>
             <a:r>
-              <a:rPr lang="en-US" smtClean="0"/>
+              <a:rPr lang="en-US"/>
               <a:t>Click to edit Master text styles</a:t>
             </a:r>
           </a:p>
           <a:p>
             <a:pPr lvl="1"/>
             <a:r>
-              <a:rPr lang="en-US" smtClean="0"/>
+              <a:rPr lang="en-US"/>
               <a:t>Second level</a:t>
             </a:r>
           </a:p>
           <a:p>
             <a:pPr lvl="2"/>
             <a:r>
-              <a:rPr lang="en-US" smtClean="0"/>
+              <a:rPr lang="en-US"/>
               <a:t>Third level</a:t>
             </a:r>
           </a:p>
           <a:p>
             <a:pPr lvl="3"/>
             <a:r>
-              <a:rPr lang="en-US" smtClean="0"/>
+              <a:rPr lang="en-US"/>
               <a:t>Fourth level</a:t>
             </a:r>
           </a:p>
           <a:p>
             <a:pPr lvl="4"/>
             <a:r>
-              <a:rPr lang="en-US" smtClean="0"/>
+              <a:rPr lang="en-US"/>
               <a:t>Fifth level</a:t>
             </a:r>
-            <a:endParaRPr lang="en-US"/>
           </a:p>
         </p:txBody>
       </p:sp>
@@ -1355,7 +1359,7 @@
           <a:p>
             <a:fld id="{5BCAD085-E8A6-8845-BD4E-CB4CCA059FC4}" type="datetimeFigureOut">
               <a:rPr lang="en-US" smtClean="0"/>
-              <a:t>1/27/13</a:t>
+              <a:t>5/5/26</a:t>
             </a:fld>
             <a:endParaRPr lang="en-US"/>
           </a:p>
@@ -1453,10 +1457,9 @@
           </a:lstStyle>
           <a:p>
             <a:r>
-              <a:rPr lang="en-US" smtClean="0"/>
+              <a:rPr lang="en-US"/>
               <a:t>Click to edit Master title style</a:t>
             </a:r>
-            <a:endParaRPr lang="en-US"/>
           </a:p>
         </p:txBody>
       </p:sp>
@@ -1519,7 +1522,7 @@
           <a:p>
             <a:pPr lvl="0"/>
             <a:r>
-              <a:rPr lang="en-US" smtClean="0"/>
+              <a:rPr lang="en-US"/>
               <a:t>Click to edit Master text styles</a:t>
             </a:r>
           </a:p>
@@ -1575,38 +1578,37 @@
           <a:p>
             <a:pPr lvl="0"/>
             <a:r>
-              <a:rPr lang="en-US" smtClean="0"/>
+              <a:rPr lang="en-US"/>
               <a:t>Click to edit Master text styles</a:t>
             </a:r>
           </a:p>
           <a:p>
             <a:pPr lvl="1"/>
             <a:r>
-              <a:rPr lang="en-US" smtClean="0"/>
+              <a:rPr lang="en-US"/>
               <a:t>Second level</a:t>
             </a:r>
           </a:p>
           <a:p>
             <a:pPr lvl="2"/>
             <a:r>
-              <a:rPr lang="en-US" smtClean="0"/>
+              <a:rPr lang="en-US"/>
               <a:t>Third level</a:t>
             </a:r>
           </a:p>
           <a:p>
             <a:pPr lvl="3"/>
             <a:r>
-              <a:rPr lang="en-US" smtClean="0"/>
+              <a:rPr lang="en-US"/>
               <a:t>Fourth level</a:t>
             </a:r>
           </a:p>
           <a:p>
             <a:pPr lvl="4"/>
             <a:r>
-              <a:rPr lang="en-US" smtClean="0"/>
+              <a:rPr lang="en-US"/>
               <a:t>Fifth level</a:t>
             </a:r>
-            <a:endParaRPr lang="en-US"/>
           </a:p>
         </p:txBody>
       </p:sp>
@@ -1669,7 +1671,7 @@
           <a:p>
             <a:pPr lvl="0"/>
             <a:r>
-              <a:rPr lang="en-US" smtClean="0"/>
+              <a:rPr lang="en-US"/>
               <a:t>Click to edit Master text styles</a:t>
             </a:r>
           </a:p>
@@ -1725,38 +1727,37 @@
           <a:p>
             <a:pPr lvl="0"/>
             <a:r>
-              <a:rPr lang="en-US" smtClean="0"/>
+              <a:rPr lang="en-US"/>
               <a:t>Click to edit Master text styles</a:t>
             </a:r>
           </a:p>
           <a:p>
             <a:pPr lvl="1"/>
             <a:r>
-              <a:rPr lang="en-US" smtClean="0"/>
+              <a:rPr lang="en-US"/>
               <a:t>Second level</a:t>
             </a:r>
           </a:p>
           <a:p>
             <a:pPr lvl="2"/>
             <a:r>
-              <a:rPr lang="en-US" smtClean="0"/>
+              <a:rPr lang="en-US"/>
               <a:t>Third level</a:t>
             </a:r>
           </a:p>
           <a:p>
             <a:pPr lvl="3"/>
             <a:r>
-              <a:rPr lang="en-US" smtClean="0"/>
+              <a:rPr lang="en-US"/>
               <a:t>Fourth level</a:t>
             </a:r>
           </a:p>
           <a:p>
             <a:pPr lvl="4"/>
             <a:r>
-              <a:rPr lang="en-US" smtClean="0"/>
+              <a:rPr lang="en-US"/>
               <a:t>Fifth level</a:t>
             </a:r>
-            <a:endParaRPr lang="en-US"/>
           </a:p>
         </p:txBody>
       </p:sp>
@@ -1777,7 +1778,7 @@
           <a:p>
             <a:fld id="{5BCAD085-E8A6-8845-BD4E-CB4CCA059FC4}" type="datetimeFigureOut">
               <a:rPr lang="en-US" smtClean="0"/>
-              <a:t>1/27/13</a:t>
+              <a:t>5/5/26</a:t>
             </a:fld>
             <a:endParaRPr lang="en-US"/>
           </a:p>
@@ -1871,10 +1872,9 @@
           <a:lstStyle/>
           <a:p>
             <a:r>
-              <a:rPr lang="en-US" smtClean="0"/>
+              <a:rPr lang="en-US"/>
               <a:t>Click to edit Master title style</a:t>
             </a:r>
-            <a:endParaRPr lang="en-US"/>
           </a:p>
         </p:txBody>
       </p:sp>
@@ -1895,7 +1895,7 @@
           <a:p>
             <a:fld id="{5BCAD085-E8A6-8845-BD4E-CB4CCA059FC4}" type="datetimeFigureOut">
               <a:rPr lang="en-US" smtClean="0"/>
-              <a:t>1/27/13</a:t>
+              <a:t>5/5/26</a:t>
             </a:fld>
             <a:endParaRPr lang="en-US"/>
           </a:p>
@@ -1990,7 +1990,7 @@
           <a:p>
             <a:fld id="{5BCAD085-E8A6-8845-BD4E-CB4CCA059FC4}" type="datetimeFigureOut">
               <a:rPr lang="en-US" smtClean="0"/>
-              <a:t>1/27/13</a:t>
+              <a:t>5/5/26</a:t>
             </a:fld>
             <a:endParaRPr lang="en-US"/>
           </a:p>
@@ -2093,10 +2093,9 @@
           </a:lstStyle>
           <a:p>
             <a:r>
-              <a:rPr lang="en-US" smtClean="0"/>
+              <a:rPr lang="en-US"/>
               <a:t>Click to edit Master title style</a:t>
             </a:r>
-            <a:endParaRPr lang="en-US"/>
           </a:p>
         </p:txBody>
       </p:sp>
@@ -2150,38 +2149,37 @@
           <a:p>
             <a:pPr lvl="0"/>
             <a:r>
-              <a:rPr lang="en-US" smtClean="0"/>
+              <a:rPr lang="en-US"/>
               <a:t>Click to edit Master text styles</a:t>
             </a:r>
           </a:p>
           <a:p>
             <a:pPr lvl="1"/>
             <a:r>
-              <a:rPr lang="en-US" smtClean="0"/>
+              <a:rPr lang="en-US"/>
               <a:t>Second level</a:t>
             </a:r>
           </a:p>
           <a:p>
             <a:pPr lvl="2"/>
             <a:r>
-              <a:rPr lang="en-US" smtClean="0"/>
+              <a:rPr lang="en-US"/>
               <a:t>Third level</a:t>
             </a:r>
           </a:p>
           <a:p>
             <a:pPr lvl="3"/>
             <a:r>
-              <a:rPr lang="en-US" smtClean="0"/>
+              <a:rPr lang="en-US"/>
               <a:t>Fourth level</a:t>
             </a:r>
           </a:p>
           <a:p>
             <a:pPr lvl="4"/>
             <a:r>
-              <a:rPr lang="en-US" smtClean="0"/>
+              <a:rPr lang="en-US"/>
               <a:t>Fifth level</a:t>
             </a:r>
-            <a:endParaRPr lang="en-US"/>
           </a:p>
         </p:txBody>
       </p:sp>
@@ -2244,7 +2242,7 @@
           <a:p>
             <a:pPr lvl="0"/>
             <a:r>
-              <a:rPr lang="en-US" smtClean="0"/>
+              <a:rPr lang="en-US"/>
               <a:t>Click to edit Master text styles</a:t>
             </a:r>
           </a:p>
@@ -2267,7 +2265,7 @@
           <a:p>
             <a:fld id="{5BCAD085-E8A6-8845-BD4E-CB4CCA059FC4}" type="datetimeFigureOut">
               <a:rPr lang="en-US" smtClean="0"/>
-              <a:t>1/27/13</a:t>
+              <a:t>5/5/26</a:t>
             </a:fld>
             <a:endParaRPr lang="en-US"/>
           </a:p>
@@ -2370,10 +2368,9 @@
           </a:lstStyle>
           <a:p>
             <a:r>
-              <a:rPr lang="en-US" smtClean="0"/>
+              <a:rPr lang="en-US"/>
               <a:t>Click to edit Master title style</a:t>
             </a:r>
-            <a:endParaRPr lang="en-US"/>
           </a:p>
         </p:txBody>
       </p:sp>
@@ -2497,7 +2494,7 @@
           <a:p>
             <a:pPr lvl="0"/>
             <a:r>
-              <a:rPr lang="en-US" smtClean="0"/>
+              <a:rPr lang="en-US"/>
               <a:t>Click to edit Master text styles</a:t>
             </a:r>
           </a:p>
@@ -2520,7 +2517,7 @@
           <a:p>
             <a:fld id="{5BCAD085-E8A6-8845-BD4E-CB4CCA059FC4}" type="datetimeFigureOut">
               <a:rPr lang="en-US" smtClean="0"/>
-              <a:t>1/27/13</a:t>
+              <a:t>5/5/26</a:t>
             </a:fld>
             <a:endParaRPr lang="en-US"/>
           </a:p>
@@ -2629,10 +2626,9 @@
           <a:lstStyle/>
           <a:p>
             <a:r>
-              <a:rPr lang="en-US" smtClean="0"/>
+              <a:rPr lang="en-US"/>
               <a:t>Click to edit Master title style</a:t>
             </a:r>
-            <a:endParaRPr lang="en-US"/>
           </a:p>
         </p:txBody>
       </p:sp>
@@ -2663,38 +2659,37 @@
           <a:p>
             <a:pPr lvl="0"/>
             <a:r>
-              <a:rPr lang="en-US" smtClean="0"/>
+              <a:rPr lang="en-US"/>
               <a:t>Click to edit Master text styles</a:t>
             </a:r>
           </a:p>
           <a:p>
             <a:pPr lvl="1"/>
             <a:r>
-              <a:rPr lang="en-US" smtClean="0"/>
+              <a:rPr lang="en-US"/>
               <a:t>Second level</a:t>
             </a:r>
           </a:p>
           <a:p>
             <a:pPr lvl="2"/>
             <a:r>
-              <a:rPr lang="en-US" smtClean="0"/>
+              <a:rPr lang="en-US"/>
               <a:t>Third level</a:t>
             </a:r>
           </a:p>
           <a:p>
             <a:pPr lvl="3"/>
             <a:r>
-              <a:rPr lang="en-US" smtClean="0"/>
+              <a:rPr lang="en-US"/>
               <a:t>Fourth level</a:t>
             </a:r>
           </a:p>
           <a:p>
             <a:pPr lvl="4"/>
             <a:r>
-              <a:rPr lang="en-US" smtClean="0"/>
+              <a:rPr lang="en-US"/>
               <a:t>Fifth level</a:t>
             </a:r>
-            <a:endParaRPr lang="en-US"/>
           </a:p>
         </p:txBody>
       </p:sp>
@@ -2733,7 +2728,7 @@
           <a:p>
             <a:fld id="{5BCAD085-E8A6-8845-BD4E-CB4CCA059FC4}" type="datetimeFigureOut">
               <a:rPr lang="en-US" smtClean="0"/>
-              <a:t>1/27/13</a:t>
+              <a:t>5/5/26</a:t>
             </a:fld>
             <a:endParaRPr lang="en-US"/>
           </a:p>
@@ -3092,7 +3087,7 @@
 </file>
 
 <file path=ppt/slides/slide1.xml><?xml version="1.0" encoding="utf-8"?>
-<p:sld xmlns:a="http://schemas.openxmlformats.org/drawingml/2006/main" xmlns:p="http://schemas.openxmlformats.org/presentationml/2006/main" xmlns:r="http://schemas.openxmlformats.org/officeDocument/2006/relationships">
+<p:sld xmlns:a="http://schemas.openxmlformats.org/drawingml/2006/main" xmlns:r="http://schemas.openxmlformats.org/officeDocument/2006/relationships" xmlns:p="http://schemas.openxmlformats.org/presentationml/2006/main">
   <p:cSld>
     <p:spTree>
       <p:nvGrpSpPr>
@@ -3100,7 +3095,14 @@
         <p:cNvGrpSpPr/>
         <p:nvPr/>
       </p:nvGrpSpPr>
-      <p:grpSpPr/>
+      <p:grpSpPr>
+        <a:xfrm>
+          <a:off x="0" y="0"/>
+          <a:ext cx="0" cy="0"/>
+          <a:chOff x="0" y="0"/>
+          <a:chExt cx="0" cy="0"/>
+        </a:xfrm>
+      </p:grpSpPr>
       <p:sp>
         <p:nvSpPr>
           <p:cNvPr id="2" name="Rectangle 1"/>
@@ -3141,6 +3143,7 @@
           <a:lstStyle/>
           <a:p>
             <a:pPr algn="ctr"/>
+            <a:endParaRPr/>
           </a:p>
         </p:txBody>
       </p:sp>
@@ -3184,6 +3187,7 @@
           <a:lstStyle/>
           <a:p>
             <a:pPr algn="ctr"/>
+            <a:endParaRPr/>
           </a:p>
         </p:txBody>
       </p:sp>
@@ -3371,7 +3375,7 @@
 </file>
 
 <file path=ppt/slides/slide10.xml><?xml version="1.0" encoding="utf-8"?>
-<p:sld xmlns:a="http://schemas.openxmlformats.org/drawingml/2006/main" xmlns:p="http://schemas.openxmlformats.org/presentationml/2006/main" xmlns:r="http://schemas.openxmlformats.org/officeDocument/2006/relationships">
+<p:sld xmlns:a="http://schemas.openxmlformats.org/drawingml/2006/main" xmlns:r="http://schemas.openxmlformats.org/officeDocument/2006/relationships" xmlns:p="http://schemas.openxmlformats.org/presentationml/2006/main">
   <p:cSld>
     <p:spTree>
       <p:nvGrpSpPr>
@@ -3379,7 +3383,14 @@
         <p:cNvGrpSpPr/>
         <p:nvPr/>
       </p:nvGrpSpPr>
-      <p:grpSpPr/>
+      <p:grpSpPr>
+        <a:xfrm>
+          <a:off x="0" y="0"/>
+          <a:ext cx="0" cy="0"/>
+          <a:chOff x="0" y="0"/>
+          <a:chExt cx="0" cy="0"/>
+        </a:xfrm>
+      </p:grpSpPr>
       <p:sp>
         <p:nvSpPr>
           <p:cNvPr id="2" name="Rectangle 1"/>
@@ -3420,6 +3431,7 @@
           <a:lstStyle/>
           <a:p>
             <a:pPr algn="ctr"/>
+            <a:endParaRPr/>
           </a:p>
         </p:txBody>
       </p:sp>
@@ -3903,7 +3915,7 @@
 </file>
 
 <file path=ppt/slides/slide11.xml><?xml version="1.0" encoding="utf-8"?>
-<p:sld xmlns:a="http://schemas.openxmlformats.org/drawingml/2006/main" xmlns:p="http://schemas.openxmlformats.org/presentationml/2006/main" xmlns:r="http://schemas.openxmlformats.org/officeDocument/2006/relationships">
+<p:sld xmlns:a="http://schemas.openxmlformats.org/drawingml/2006/main" xmlns:r="http://schemas.openxmlformats.org/officeDocument/2006/relationships" xmlns:p="http://schemas.openxmlformats.org/presentationml/2006/main">
   <p:cSld>
     <p:spTree>
       <p:nvGrpSpPr>
@@ -3911,7 +3923,14 @@
         <p:cNvGrpSpPr/>
         <p:nvPr/>
       </p:nvGrpSpPr>
-      <p:grpSpPr/>
+      <p:grpSpPr>
+        <a:xfrm>
+          <a:off x="0" y="0"/>
+          <a:ext cx="0" cy="0"/>
+          <a:chOff x="0" y="0"/>
+          <a:chExt cx="0" cy="0"/>
+        </a:xfrm>
+      </p:grpSpPr>
       <p:sp>
         <p:nvSpPr>
           <p:cNvPr id="2" name="Rectangle 1"/>
@@ -3952,6 +3971,7 @@
           <a:lstStyle/>
           <a:p>
             <a:pPr algn="ctr"/>
+            <a:endParaRPr/>
           </a:p>
         </p:txBody>
       </p:sp>
@@ -4100,6 +4120,7 @@
           <a:lstStyle/>
           <a:p>
             <a:pPr algn="ctr"/>
+            <a:endParaRPr/>
           </a:p>
         </p:txBody>
       </p:sp>
@@ -4283,6 +4304,7 @@
           <a:lstStyle/>
           <a:p>
             <a:pPr algn="ctr"/>
+            <a:endParaRPr/>
           </a:p>
         </p:txBody>
       </p:sp>
@@ -4466,6 +4488,7 @@
           <a:lstStyle/>
           <a:p>
             <a:pPr algn="ctr"/>
+            <a:endParaRPr/>
           </a:p>
         </p:txBody>
       </p:sp>
@@ -4649,6 +4672,7 @@
           <a:lstStyle/>
           <a:p>
             <a:pPr algn="ctr"/>
+            <a:endParaRPr/>
           </a:p>
         </p:txBody>
       </p:sp>
@@ -4832,6 +4856,7 @@
           <a:lstStyle/>
           <a:p>
             <a:pPr algn="ctr"/>
+            <a:endParaRPr/>
           </a:p>
         </p:txBody>
       </p:sp>
@@ -5015,6 +5040,7 @@
           <a:lstStyle/>
           <a:p>
             <a:pPr algn="ctr"/>
+            <a:endParaRPr/>
           </a:p>
         </p:txBody>
       </p:sp>
@@ -5198,6 +5224,7 @@
           <a:lstStyle/>
           <a:p>
             <a:pPr algn="ctr"/>
+            <a:endParaRPr/>
           </a:p>
         </p:txBody>
       </p:sp>
@@ -5451,6 +5478,7 @@
           <a:lstStyle/>
           <a:p>
             <a:pPr algn="ctr"/>
+            <a:endParaRPr/>
           </a:p>
         </p:txBody>
       </p:sp>
@@ -6108,6 +6136,7 @@
           <a:lstStyle/>
           <a:p>
             <a:pPr algn="ctr"/>
+            <a:endParaRPr/>
           </a:p>
         </p:txBody>
       </p:sp>
@@ -6225,7 +6254,7 @@
 </file>
 
 <file path=ppt/slides/slide12.xml><?xml version="1.0" encoding="utf-8"?>
-<p:sld xmlns:a="http://schemas.openxmlformats.org/drawingml/2006/main" xmlns:p="http://schemas.openxmlformats.org/presentationml/2006/main" xmlns:r="http://schemas.openxmlformats.org/officeDocument/2006/relationships">
+<p:sld xmlns:a="http://schemas.openxmlformats.org/drawingml/2006/main" xmlns:r="http://schemas.openxmlformats.org/officeDocument/2006/relationships" xmlns:p="http://schemas.openxmlformats.org/presentationml/2006/main">
   <p:cSld>
     <p:spTree>
       <p:nvGrpSpPr>
@@ -6233,7 +6262,14 @@
         <p:cNvGrpSpPr/>
         <p:nvPr/>
       </p:nvGrpSpPr>
-      <p:grpSpPr/>
+      <p:grpSpPr>
+        <a:xfrm>
+          <a:off x="0" y="0"/>
+          <a:ext cx="0" cy="0"/>
+          <a:chOff x="0" y="0"/>
+          <a:chExt cx="0" cy="0"/>
+        </a:xfrm>
+      </p:grpSpPr>
       <p:sp>
         <p:nvSpPr>
           <p:cNvPr id="2" name="Rectangle 1"/>
@@ -6274,6 +6310,7 @@
           <a:lstStyle/>
           <a:p>
             <a:pPr algn="ctr"/>
+            <a:endParaRPr/>
           </a:p>
         </p:txBody>
       </p:sp>
@@ -6363,8 +6400,8 @@
         </p:blipFill>
         <p:spPr>
           <a:xfrm>
-            <a:off x="457200" y="1280160"/>
-            <a:ext cx="9179859" cy="3657600"/>
+            <a:off x="457201" y="1451025"/>
+            <a:ext cx="7381248" cy="2940966"/>
           </a:xfrm>
           <a:prstGeom prst="rect">
             <a:avLst/>
@@ -6379,7 +6416,7 @@
         </p:nvSpPr>
         <p:spPr>
           <a:xfrm>
-            <a:off x="6858000" y="1280160"/>
+            <a:off x="8696123" y="1249432"/>
             <a:ext cx="5120640" cy="365760"/>
           </a:xfrm>
           <a:prstGeom prst="rect">
@@ -6395,7 +6432,7 @@
           <a:p>
             <a:pPr algn="l"/>
             <a:r>
-              <a:rPr sz="1800" b="1">
+              <a:rPr sz="1800" b="1" dirty="0">
                 <a:solidFill>
                   <a:srgbClr val="186F82"/>
                 </a:solidFill>
@@ -6414,8 +6451,8 @@
         </p:nvSpPr>
         <p:spPr>
           <a:xfrm>
-            <a:off x="6858000" y="1691640"/>
-            <a:ext cx="5120640" cy="1828800"/>
+            <a:off x="7838449" y="1692584"/>
+            <a:ext cx="4586886" cy="802784"/>
           </a:xfrm>
           <a:prstGeom prst="rect">
             <a:avLst/>
@@ -6434,7 +6471,7 @@
               </a:spcAft>
             </a:pPr>
             <a:r>
-              <a:rPr sz="1400">
+              <a:rPr sz="1400" dirty="0">
                 <a:solidFill>
                   <a:srgbClr val="1F2D5C"/>
                 </a:solidFill>
@@ -6450,7 +6487,7 @@
               </a:spcAft>
             </a:pPr>
             <a:r>
-              <a:rPr sz="1400">
+              <a:rPr sz="1400" dirty="0">
                 <a:solidFill>
                   <a:srgbClr val="1F2D5C"/>
                 </a:solidFill>
@@ -6469,7 +6506,7 @@
         </p:nvSpPr>
         <p:spPr>
           <a:xfrm>
-            <a:off x="6858000" y="3108960"/>
+            <a:off x="7955280" y="2724912"/>
             <a:ext cx="5120640" cy="365760"/>
           </a:xfrm>
           <a:prstGeom prst="rect">
@@ -6485,7 +6522,7 @@
           <a:p>
             <a:pPr algn="l"/>
             <a:r>
-              <a:rPr sz="1800" b="1">
+              <a:rPr sz="1800" b="1" dirty="0">
                 <a:solidFill>
                   <a:srgbClr val="E56B5C"/>
                 </a:solidFill>
@@ -6504,7 +6541,7 @@
         </p:nvSpPr>
         <p:spPr>
           <a:xfrm>
-            <a:off x="6858000" y="3520440"/>
+            <a:off x="7911440" y="3168396"/>
             <a:ext cx="5120640" cy="2286000"/>
           </a:xfrm>
           <a:prstGeom prst="rect">
@@ -6524,7 +6561,7 @@
               </a:spcAft>
             </a:pPr>
             <a:r>
-              <a:rPr sz="1300" b="1">
+              <a:rPr sz="1300" b="1" dirty="0">
                 <a:solidFill>
                   <a:srgbClr val="1F2D5C"/>
                 </a:solidFill>
@@ -6533,7 +6570,7 @@
               <a:t>AUC 0.848 → 0.773</a:t>
             </a:r>
             <a:r>
-              <a:rPr sz="1300" b="0">
+              <a:rPr sz="1300" b="0" dirty="0">
                 <a:solidFill>
                   <a:srgbClr val="1F2D5C"/>
                 </a:solidFill>
@@ -6549,7 +6586,7 @@
               </a:spcAft>
             </a:pPr>
             <a:r>
-              <a:rPr sz="1300">
+              <a:rPr sz="1300" dirty="0">
                 <a:solidFill>
                   <a:srgbClr val="1F2D5C"/>
                 </a:solidFill>
@@ -6565,7 +6602,7 @@
               </a:spcAft>
             </a:pPr>
             <a:r>
-              <a:rPr sz="1300">
+              <a:rPr sz="1300" dirty="0">
                 <a:solidFill>
                   <a:srgbClr val="1F2D5C"/>
                 </a:solidFill>
@@ -6581,7 +6618,7 @@
               </a:spcAft>
             </a:pPr>
             <a:r>
-              <a:rPr sz="1300" b="0">
+              <a:rPr sz="1300" b="0" dirty="0">
                 <a:solidFill>
                   <a:srgbClr val="1F2D5C"/>
                 </a:solidFill>
@@ -6590,7 +6627,7 @@
               <a:t>Achieved with </a:t>
             </a:r>
             <a:r>
-              <a:rPr sz="1300" b="1">
+              <a:rPr sz="1300" b="1" dirty="0">
                 <a:solidFill>
                   <a:srgbClr val="1F2D5C"/>
                 </a:solidFill>
@@ -6641,6 +6678,7 @@
           <a:lstStyle/>
           <a:p>
             <a:pPr algn="ctr"/>
+            <a:endParaRPr/>
           </a:p>
         </p:txBody>
       </p:sp>
@@ -6793,7 +6831,7 @@
 </file>
 
 <file path=ppt/slides/slide13.xml><?xml version="1.0" encoding="utf-8"?>
-<p:sld xmlns:a="http://schemas.openxmlformats.org/drawingml/2006/main" xmlns:p="http://schemas.openxmlformats.org/presentationml/2006/main" xmlns:r="http://schemas.openxmlformats.org/officeDocument/2006/relationships">
+<p:sld xmlns:a="http://schemas.openxmlformats.org/drawingml/2006/main" xmlns:r="http://schemas.openxmlformats.org/officeDocument/2006/relationships" xmlns:p="http://schemas.openxmlformats.org/presentationml/2006/main">
   <p:cSld>
     <p:spTree>
       <p:nvGrpSpPr>
@@ -6801,7 +6839,14 @@
         <p:cNvGrpSpPr/>
         <p:nvPr/>
       </p:nvGrpSpPr>
-      <p:grpSpPr/>
+      <p:grpSpPr>
+        <a:xfrm>
+          <a:off x="0" y="0"/>
+          <a:ext cx="0" cy="0"/>
+          <a:chOff x="0" y="0"/>
+          <a:chExt cx="0" cy="0"/>
+        </a:xfrm>
+      </p:grpSpPr>
       <p:sp>
         <p:nvSpPr>
           <p:cNvPr id="2" name="Rectangle 1"/>
@@ -6842,6 +6887,7 @@
           <a:lstStyle/>
           <a:p>
             <a:pPr algn="ctr"/>
+            <a:endParaRPr/>
           </a:p>
         </p:txBody>
       </p:sp>
@@ -7294,6 +7340,7 @@
           <a:lstStyle/>
           <a:p>
             <a:pPr algn="ctr"/>
+            <a:endParaRPr/>
           </a:p>
         </p:txBody>
       </p:sp>
@@ -7446,7 +7493,7 @@
 </file>
 
 <file path=ppt/slides/slide14.xml><?xml version="1.0" encoding="utf-8"?>
-<p:sld xmlns:a="http://schemas.openxmlformats.org/drawingml/2006/main" xmlns:p="http://schemas.openxmlformats.org/presentationml/2006/main" xmlns:r="http://schemas.openxmlformats.org/officeDocument/2006/relationships">
+<p:sld xmlns:a="http://schemas.openxmlformats.org/drawingml/2006/main" xmlns:r="http://schemas.openxmlformats.org/officeDocument/2006/relationships" xmlns:p="http://schemas.openxmlformats.org/presentationml/2006/main">
   <p:cSld>
     <p:spTree>
       <p:nvGrpSpPr>
@@ -7454,7 +7501,14 @@
         <p:cNvGrpSpPr/>
         <p:nvPr/>
       </p:nvGrpSpPr>
-      <p:grpSpPr/>
+      <p:grpSpPr>
+        <a:xfrm>
+          <a:off x="0" y="0"/>
+          <a:ext cx="0" cy="0"/>
+          <a:chOff x="0" y="0"/>
+          <a:chExt cx="0" cy="0"/>
+        </a:xfrm>
+      </p:grpSpPr>
       <p:sp>
         <p:nvSpPr>
           <p:cNvPr id="2" name="Rectangle 1"/>
@@ -7495,6 +7549,7 @@
           <a:lstStyle/>
           <a:p>
             <a:pPr algn="ctr"/>
+            <a:endParaRPr/>
           </a:p>
         </p:txBody>
       </p:sp>
@@ -7965,6 +8020,7 @@
           <a:lstStyle/>
           <a:p>
             <a:pPr algn="ctr"/>
+            <a:endParaRPr/>
           </a:p>
         </p:txBody>
       </p:sp>
@@ -8117,7 +8173,7 @@
 </file>
 
 <file path=ppt/slides/slide2.xml><?xml version="1.0" encoding="utf-8"?>
-<p:sld xmlns:a="http://schemas.openxmlformats.org/drawingml/2006/main" xmlns:p="http://schemas.openxmlformats.org/presentationml/2006/main" xmlns:r="http://schemas.openxmlformats.org/officeDocument/2006/relationships">
+<p:sld xmlns:a="http://schemas.openxmlformats.org/drawingml/2006/main" xmlns:r="http://schemas.openxmlformats.org/officeDocument/2006/relationships" xmlns:p="http://schemas.openxmlformats.org/presentationml/2006/main">
   <p:cSld>
     <p:spTree>
       <p:nvGrpSpPr>
@@ -8125,7 +8181,14 @@
         <p:cNvGrpSpPr/>
         <p:nvPr/>
       </p:nvGrpSpPr>
-      <p:grpSpPr/>
+      <p:grpSpPr>
+        <a:xfrm>
+          <a:off x="0" y="0"/>
+          <a:ext cx="0" cy="0"/>
+          <a:chOff x="0" y="0"/>
+          <a:chExt cx="0" cy="0"/>
+        </a:xfrm>
+      </p:grpSpPr>
       <p:sp>
         <p:nvSpPr>
           <p:cNvPr id="2" name="Rectangle 1"/>
@@ -8166,6 +8229,7 @@
           <a:lstStyle/>
           <a:p>
             <a:pPr algn="ctr"/>
+            <a:endParaRPr/>
           </a:p>
         </p:txBody>
       </p:sp>
@@ -8566,6 +8630,7 @@
           <a:lstStyle/>
           <a:p>
             <a:pPr algn="ctr"/>
+            <a:endParaRPr/>
           </a:p>
         </p:txBody>
       </p:sp>
@@ -8718,7 +8783,7 @@
 </file>
 
 <file path=ppt/slides/slide3.xml><?xml version="1.0" encoding="utf-8"?>
-<p:sld xmlns:a="http://schemas.openxmlformats.org/drawingml/2006/main" xmlns:p="http://schemas.openxmlformats.org/presentationml/2006/main" xmlns:r="http://schemas.openxmlformats.org/officeDocument/2006/relationships">
+<p:sld xmlns:a="http://schemas.openxmlformats.org/drawingml/2006/main" xmlns:r="http://schemas.openxmlformats.org/officeDocument/2006/relationships" xmlns:p="http://schemas.openxmlformats.org/presentationml/2006/main">
   <p:cSld>
     <p:spTree>
       <p:nvGrpSpPr>
@@ -8726,7 +8791,14 @@
         <p:cNvGrpSpPr/>
         <p:nvPr/>
       </p:nvGrpSpPr>
-      <p:grpSpPr/>
+      <p:grpSpPr>
+        <a:xfrm>
+          <a:off x="0" y="0"/>
+          <a:ext cx="0" cy="0"/>
+          <a:chOff x="0" y="0"/>
+          <a:chExt cx="0" cy="0"/>
+        </a:xfrm>
+      </p:grpSpPr>
       <p:sp>
         <p:nvSpPr>
           <p:cNvPr id="2" name="Rectangle 1"/>
@@ -8767,6 +8839,7 @@
           <a:lstStyle/>
           <a:p>
             <a:pPr algn="ctr"/>
+            <a:endParaRPr/>
           </a:p>
         </p:txBody>
       </p:sp>
@@ -8880,6 +8953,7 @@
           <a:lstStyle/>
           <a:p>
             <a:pPr algn="ctr"/>
+            <a:endParaRPr/>
           </a:p>
         </p:txBody>
       </p:sp>
@@ -8923,6 +8997,7 @@
           <a:lstStyle/>
           <a:p>
             <a:pPr algn="ctr"/>
+            <a:endParaRPr/>
           </a:p>
         </p:txBody>
       </p:sp>
@@ -9037,6 +9112,7 @@
           <a:lstStyle/>
           <a:p>
             <a:pPr algn="ctr"/>
+            <a:endParaRPr/>
           </a:p>
         </p:txBody>
       </p:sp>
@@ -9080,6 +9156,7 @@
           <a:lstStyle/>
           <a:p>
             <a:pPr algn="ctr"/>
+            <a:endParaRPr/>
           </a:p>
         </p:txBody>
       </p:sp>
@@ -9194,6 +9271,7 @@
           <a:lstStyle/>
           <a:p>
             <a:pPr algn="ctr"/>
+            <a:endParaRPr/>
           </a:p>
         </p:txBody>
       </p:sp>
@@ -9237,6 +9315,7 @@
           <a:lstStyle/>
           <a:p>
             <a:pPr algn="ctr"/>
+            <a:endParaRPr/>
           </a:p>
         </p:txBody>
       </p:sp>
@@ -9351,6 +9430,7 @@
           <a:lstStyle/>
           <a:p>
             <a:pPr algn="ctr"/>
+            <a:endParaRPr/>
           </a:p>
         </p:txBody>
       </p:sp>
@@ -9503,7 +9583,7 @@
 </file>
 
 <file path=ppt/slides/slide4.xml><?xml version="1.0" encoding="utf-8"?>
-<p:sld xmlns:a="http://schemas.openxmlformats.org/drawingml/2006/main" xmlns:p="http://schemas.openxmlformats.org/presentationml/2006/main" xmlns:r="http://schemas.openxmlformats.org/officeDocument/2006/relationships">
+<p:sld xmlns:a="http://schemas.openxmlformats.org/drawingml/2006/main" xmlns:r="http://schemas.openxmlformats.org/officeDocument/2006/relationships" xmlns:p="http://schemas.openxmlformats.org/presentationml/2006/main">
   <p:cSld>
     <p:spTree>
       <p:nvGrpSpPr>
@@ -9511,7 +9591,14 @@
         <p:cNvGrpSpPr/>
         <p:nvPr/>
       </p:nvGrpSpPr>
-      <p:grpSpPr/>
+      <p:grpSpPr>
+        <a:xfrm>
+          <a:off x="0" y="0"/>
+          <a:ext cx="0" cy="0"/>
+          <a:chOff x="0" y="0"/>
+          <a:chExt cx="0" cy="0"/>
+        </a:xfrm>
+      </p:grpSpPr>
       <p:sp>
         <p:nvSpPr>
           <p:cNvPr id="2" name="Rectangle 1"/>
@@ -9552,6 +9639,7 @@
           <a:lstStyle/>
           <a:p>
             <a:pPr algn="ctr"/>
+            <a:endParaRPr/>
           </a:p>
         </p:txBody>
       </p:sp>
@@ -9936,6 +10024,7 @@
           <a:lstStyle/>
           <a:p>
             <a:pPr algn="ctr"/>
+            <a:endParaRPr/>
           </a:p>
         </p:txBody>
       </p:sp>
@@ -10085,6 +10174,7 @@
           <a:lstStyle/>
           <a:p>
             <a:pPr algn="ctr"/>
+            <a:endParaRPr/>
           </a:p>
         </p:txBody>
       </p:sp>
@@ -10234,6 +10324,7 @@
           <a:lstStyle/>
           <a:p>
             <a:pPr algn="ctr"/>
+            <a:endParaRPr/>
           </a:p>
         </p:txBody>
       </p:sp>
@@ -10383,6 +10474,7 @@
           <a:lstStyle/>
           <a:p>
             <a:pPr algn="ctr"/>
+            <a:endParaRPr/>
           </a:p>
         </p:txBody>
       </p:sp>
@@ -10532,6 +10624,7 @@
           <a:lstStyle/>
           <a:p>
             <a:pPr algn="ctr"/>
+            <a:endParaRPr/>
           </a:p>
         </p:txBody>
       </p:sp>
@@ -10685,7 +10778,7 @@
 </file>
 
 <file path=ppt/slides/slide5.xml><?xml version="1.0" encoding="utf-8"?>
-<p:sld xmlns:a="http://schemas.openxmlformats.org/drawingml/2006/main" xmlns:p="http://schemas.openxmlformats.org/presentationml/2006/main" xmlns:r="http://schemas.openxmlformats.org/officeDocument/2006/relationships">
+<p:sld xmlns:a="http://schemas.openxmlformats.org/drawingml/2006/main" xmlns:r="http://schemas.openxmlformats.org/officeDocument/2006/relationships" xmlns:p="http://schemas.openxmlformats.org/presentationml/2006/main">
   <p:cSld>
     <p:spTree>
       <p:nvGrpSpPr>
@@ -10693,7 +10786,14 @@
         <p:cNvGrpSpPr/>
         <p:nvPr/>
       </p:nvGrpSpPr>
-      <p:grpSpPr/>
+      <p:grpSpPr>
+        <a:xfrm>
+          <a:off x="0" y="0"/>
+          <a:ext cx="0" cy="0"/>
+          <a:chOff x="0" y="0"/>
+          <a:chExt cx="0" cy="0"/>
+        </a:xfrm>
+      </p:grpSpPr>
       <p:sp>
         <p:nvSpPr>
           <p:cNvPr id="2" name="Rectangle 1"/>
@@ -10734,6 +10834,7 @@
           <a:lstStyle/>
           <a:p>
             <a:pPr algn="ctr"/>
+            <a:endParaRPr/>
           </a:p>
         </p:txBody>
       </p:sp>
@@ -11126,6 +11227,7 @@
           <a:lstStyle/>
           <a:p>
             <a:pPr algn="ctr"/>
+            <a:endParaRPr/>
           </a:p>
         </p:txBody>
       </p:sp>
@@ -11278,7 +11380,7 @@
 </file>
 
 <file path=ppt/slides/slide6.xml><?xml version="1.0" encoding="utf-8"?>
-<p:sld xmlns:a="http://schemas.openxmlformats.org/drawingml/2006/main" xmlns:p="http://schemas.openxmlformats.org/presentationml/2006/main" xmlns:r="http://schemas.openxmlformats.org/officeDocument/2006/relationships">
+<p:sld xmlns:a="http://schemas.openxmlformats.org/drawingml/2006/main" xmlns:r="http://schemas.openxmlformats.org/officeDocument/2006/relationships" xmlns:p="http://schemas.openxmlformats.org/presentationml/2006/main">
   <p:cSld>
     <p:spTree>
       <p:nvGrpSpPr>
@@ -11286,7 +11388,14 @@
         <p:cNvGrpSpPr/>
         <p:nvPr/>
       </p:nvGrpSpPr>
-      <p:grpSpPr/>
+      <p:grpSpPr>
+        <a:xfrm>
+          <a:off x="0" y="0"/>
+          <a:ext cx="0" cy="0"/>
+          <a:chOff x="0" y="0"/>
+          <a:chExt cx="0" cy="0"/>
+        </a:xfrm>
+      </p:grpSpPr>
       <p:sp>
         <p:nvSpPr>
           <p:cNvPr id="2" name="Rectangle 1"/>
@@ -11327,6 +11436,7 @@
           <a:lstStyle/>
           <a:p>
             <a:pPr algn="ctr"/>
+            <a:endParaRPr/>
           </a:p>
         </p:txBody>
       </p:sp>
@@ -11440,6 +11550,7 @@
           <a:lstStyle/>
           <a:p>
             <a:pPr algn="ctr"/>
+            <a:endParaRPr/>
           </a:p>
         </p:txBody>
       </p:sp>
@@ -11483,6 +11594,7 @@
           <a:lstStyle/>
           <a:p>
             <a:pPr algn="ctr"/>
+            <a:endParaRPr/>
           </a:p>
         </p:txBody>
       </p:sp>
@@ -11597,6 +11709,7 @@
           <a:lstStyle/>
           <a:p>
             <a:pPr algn="ctr"/>
+            <a:endParaRPr/>
           </a:p>
         </p:txBody>
       </p:sp>
@@ -11640,6 +11753,7 @@
           <a:lstStyle/>
           <a:p>
             <a:pPr algn="ctr"/>
+            <a:endParaRPr/>
           </a:p>
         </p:txBody>
       </p:sp>
@@ -11755,6 +11869,7 @@
           <a:lstStyle/>
           <a:p>
             <a:pPr algn="ctr"/>
+            <a:endParaRPr/>
           </a:p>
         </p:txBody>
       </p:sp>
@@ -11798,6 +11913,7 @@
           <a:lstStyle/>
           <a:p>
             <a:pPr algn="ctr"/>
+            <a:endParaRPr/>
           </a:p>
         </p:txBody>
       </p:sp>
@@ -11912,6 +12028,7 @@
           <a:lstStyle/>
           <a:p>
             <a:pPr algn="ctr"/>
+            <a:endParaRPr/>
           </a:p>
         </p:txBody>
       </p:sp>
@@ -11955,6 +12072,7 @@
           <a:lstStyle/>
           <a:p>
             <a:pPr algn="ctr"/>
+            <a:endParaRPr/>
           </a:p>
         </p:txBody>
       </p:sp>
@@ -12069,6 +12187,7 @@
           <a:lstStyle/>
           <a:p>
             <a:pPr algn="ctr"/>
+            <a:endParaRPr/>
           </a:p>
         </p:txBody>
       </p:sp>
@@ -12112,6 +12231,7 @@
           <a:lstStyle/>
           <a:p>
             <a:pPr algn="ctr"/>
+            <a:endParaRPr/>
           </a:p>
         </p:txBody>
       </p:sp>
@@ -12226,6 +12346,7 @@
           <a:lstStyle/>
           <a:p>
             <a:pPr algn="ctr"/>
+            <a:endParaRPr/>
           </a:p>
         </p:txBody>
       </p:sp>
@@ -12269,6 +12390,7 @@
           <a:lstStyle/>
           <a:p>
             <a:pPr algn="ctr"/>
+            <a:endParaRPr/>
           </a:p>
         </p:txBody>
       </p:sp>
@@ -12419,6 +12541,7 @@
           <a:lstStyle/>
           <a:p>
             <a:pPr algn="ctr"/>
+            <a:endParaRPr/>
           </a:p>
         </p:txBody>
       </p:sp>
@@ -12510,6 +12633,7 @@
           <a:lstStyle/>
           <a:p>
             <a:pPr algn="ctr"/>
+            <a:endParaRPr/>
           </a:p>
         </p:txBody>
       </p:sp>
@@ -12601,6 +12725,7 @@
           <a:lstStyle/>
           <a:p>
             <a:pPr algn="ctr"/>
+            <a:endParaRPr/>
           </a:p>
         </p:txBody>
       </p:sp>
@@ -12692,6 +12817,7 @@
           <a:lstStyle/>
           <a:p>
             <a:pPr algn="ctr"/>
+            <a:endParaRPr/>
           </a:p>
         </p:txBody>
       </p:sp>
@@ -12783,6 +12909,7 @@
           <a:lstStyle/>
           <a:p>
             <a:pPr algn="ctr"/>
+            <a:endParaRPr/>
           </a:p>
         </p:txBody>
       </p:sp>
@@ -12874,6 +13001,7 @@
           <a:lstStyle/>
           <a:p>
             <a:pPr algn="ctr"/>
+            <a:endParaRPr/>
           </a:p>
         </p:txBody>
       </p:sp>
@@ -12965,6 +13093,7 @@
           <a:lstStyle/>
           <a:p>
             <a:pPr algn="ctr"/>
+            <a:endParaRPr/>
           </a:p>
         </p:txBody>
       </p:sp>
@@ -13117,7 +13246,7 @@
 </file>
 
 <file path=ppt/slides/slide7.xml><?xml version="1.0" encoding="utf-8"?>
-<p:sld xmlns:a="http://schemas.openxmlformats.org/drawingml/2006/main" xmlns:p="http://schemas.openxmlformats.org/presentationml/2006/main" xmlns:r="http://schemas.openxmlformats.org/officeDocument/2006/relationships">
+<p:sld xmlns:a="http://schemas.openxmlformats.org/drawingml/2006/main" xmlns:r="http://schemas.openxmlformats.org/officeDocument/2006/relationships" xmlns:p="http://schemas.openxmlformats.org/presentationml/2006/main">
   <p:cSld>
     <p:spTree>
       <p:nvGrpSpPr>
@@ -13125,7 +13254,14 @@
         <p:cNvGrpSpPr/>
         <p:nvPr/>
       </p:nvGrpSpPr>
-      <p:grpSpPr/>
+      <p:grpSpPr>
+        <a:xfrm>
+          <a:off x="0" y="0"/>
+          <a:ext cx="0" cy="0"/>
+          <a:chOff x="0" y="0"/>
+          <a:chExt cx="0" cy="0"/>
+        </a:xfrm>
+      </p:grpSpPr>
       <p:sp>
         <p:nvSpPr>
           <p:cNvPr id="2" name="Rectangle 1"/>
@@ -13166,6 +13302,7 @@
           <a:lstStyle/>
           <a:p>
             <a:pPr algn="ctr"/>
+            <a:endParaRPr/>
           </a:p>
         </p:txBody>
       </p:sp>
@@ -13279,6 +13416,7 @@
           <a:lstStyle/>
           <a:p>
             <a:pPr algn="ctr"/>
+            <a:endParaRPr/>
           </a:p>
         </p:txBody>
       </p:sp>
@@ -13322,6 +13460,7 @@
           <a:lstStyle/>
           <a:p>
             <a:pPr algn="ctr"/>
+            <a:endParaRPr/>
           </a:p>
         </p:txBody>
       </p:sp>
@@ -13470,6 +13609,7 @@
           <a:lstStyle/>
           <a:p>
             <a:pPr algn="ctr"/>
+            <a:endParaRPr/>
           </a:p>
         </p:txBody>
       </p:sp>
@@ -13513,6 +13653,7 @@
           <a:lstStyle/>
           <a:p>
             <a:pPr algn="ctr"/>
+            <a:endParaRPr/>
           </a:p>
         </p:txBody>
       </p:sp>
@@ -13661,6 +13802,7 @@
           <a:lstStyle/>
           <a:p>
             <a:pPr algn="ctr"/>
+            <a:endParaRPr/>
           </a:p>
         </p:txBody>
       </p:sp>
@@ -13704,6 +13846,7 @@
           <a:lstStyle/>
           <a:p>
             <a:pPr algn="ctr"/>
+            <a:endParaRPr/>
           </a:p>
         </p:txBody>
       </p:sp>
@@ -13888,6 +14031,7 @@
           <a:lstStyle/>
           <a:p>
             <a:pPr algn="ctr"/>
+            <a:endParaRPr/>
           </a:p>
         </p:txBody>
       </p:sp>
@@ -14001,6 +14145,7 @@
           <a:lstStyle/>
           <a:p>
             <a:pPr algn="ctr"/>
+            <a:endParaRPr/>
           </a:p>
         </p:txBody>
       </p:sp>
@@ -14114,6 +14259,7 @@
           <a:lstStyle/>
           <a:p>
             <a:pPr algn="ctr"/>
+            <a:endParaRPr/>
           </a:p>
         </p:txBody>
       </p:sp>
@@ -14227,6 +14373,7 @@
           <a:lstStyle/>
           <a:p>
             <a:pPr algn="ctr"/>
+            <a:endParaRPr/>
           </a:p>
         </p:txBody>
       </p:sp>
@@ -14340,6 +14487,7 @@
           <a:lstStyle/>
           <a:p>
             <a:pPr algn="ctr"/>
+            <a:endParaRPr/>
           </a:p>
         </p:txBody>
       </p:sp>
@@ -14453,6 +14601,7 @@
           <a:lstStyle/>
           <a:p>
             <a:pPr algn="ctr"/>
+            <a:endParaRPr/>
           </a:p>
         </p:txBody>
       </p:sp>
@@ -14605,7 +14754,7 @@
 </file>
 
 <file path=ppt/slides/slide8.xml><?xml version="1.0" encoding="utf-8"?>
-<p:sld xmlns:a="http://schemas.openxmlformats.org/drawingml/2006/main" xmlns:p="http://schemas.openxmlformats.org/presentationml/2006/main" xmlns:r="http://schemas.openxmlformats.org/officeDocument/2006/relationships">
+<p:sld xmlns:a="http://schemas.openxmlformats.org/drawingml/2006/main" xmlns:r="http://schemas.openxmlformats.org/officeDocument/2006/relationships" xmlns:p="http://schemas.openxmlformats.org/presentationml/2006/main">
   <p:cSld>
     <p:spTree>
       <p:nvGrpSpPr>
@@ -14613,7 +14762,14 @@
         <p:cNvGrpSpPr/>
         <p:nvPr/>
       </p:nvGrpSpPr>
-      <p:grpSpPr/>
+      <p:grpSpPr>
+        <a:xfrm>
+          <a:off x="0" y="0"/>
+          <a:ext cx="0" cy="0"/>
+          <a:chOff x="0" y="0"/>
+          <a:chExt cx="0" cy="0"/>
+        </a:xfrm>
+      </p:grpSpPr>
       <p:sp>
         <p:nvSpPr>
           <p:cNvPr id="2" name="Rectangle 1"/>
@@ -14654,6 +14810,7 @@
           <a:lstStyle/>
           <a:p>
             <a:pPr algn="ctr"/>
+            <a:endParaRPr/>
           </a:p>
         </p:txBody>
       </p:sp>
@@ -14815,6 +14972,7 @@
           <a:lstStyle/>
           <a:p>
             <a:pPr algn="ctr"/>
+            <a:endParaRPr/>
           </a:p>
         </p:txBody>
       </p:sp>
@@ -15208,6 +15366,7 @@
           <a:lstStyle/>
           <a:p>
             <a:pPr algn="ctr"/>
+            <a:endParaRPr/>
           </a:p>
         </p:txBody>
       </p:sp>
@@ -15325,7 +15484,7 @@
 </file>
 
 <file path=ppt/slides/slide9.xml><?xml version="1.0" encoding="utf-8"?>
-<p:sld xmlns:a="http://schemas.openxmlformats.org/drawingml/2006/main" xmlns:p="http://schemas.openxmlformats.org/presentationml/2006/main" xmlns:r="http://schemas.openxmlformats.org/officeDocument/2006/relationships">
+<p:sld xmlns:a="http://schemas.openxmlformats.org/drawingml/2006/main" xmlns:r="http://schemas.openxmlformats.org/officeDocument/2006/relationships" xmlns:p="http://schemas.openxmlformats.org/presentationml/2006/main">
   <p:cSld>
     <p:spTree>
       <p:nvGrpSpPr>
@@ -15333,7 +15492,14 @@
         <p:cNvGrpSpPr/>
         <p:nvPr/>
       </p:nvGrpSpPr>
-      <p:grpSpPr/>
+      <p:grpSpPr>
+        <a:xfrm>
+          <a:off x="0" y="0"/>
+          <a:ext cx="0" cy="0"/>
+          <a:chOff x="0" y="0"/>
+          <a:chExt cx="0" cy="0"/>
+        </a:xfrm>
+      </p:grpSpPr>
       <p:sp>
         <p:nvSpPr>
           <p:cNvPr id="2" name="Rectangle 1"/>
@@ -15374,6 +15540,7 @@
           <a:lstStyle/>
           <a:p>
             <a:pPr algn="ctr"/>
+            <a:endParaRPr/>
           </a:p>
         </p:txBody>
       </p:sp>
@@ -15487,6 +15654,7 @@
           <a:lstStyle/>
           <a:p>
             <a:pPr algn="ctr"/>
+            <a:endParaRPr/>
           </a:p>
         </p:txBody>
       </p:sp>
@@ -15530,6 +15698,7 @@
           <a:lstStyle/>
           <a:p>
             <a:pPr algn="ctr"/>
+            <a:endParaRPr/>
           </a:p>
         </p:txBody>
       </p:sp>
@@ -15713,6 +15882,7 @@
           <a:lstStyle/>
           <a:p>
             <a:pPr algn="ctr"/>
+            <a:endParaRPr/>
           </a:p>
         </p:txBody>
       </p:sp>
@@ -15756,6 +15926,7 @@
           <a:lstStyle/>
           <a:p>
             <a:pPr algn="ctr"/>
+            <a:endParaRPr/>
           </a:p>
         </p:txBody>
       </p:sp>
@@ -15930,6 +16101,7 @@
           <a:lstStyle/>
           <a:p>
             <a:pPr algn="ctr"/>
+            <a:endParaRPr/>
           </a:p>
         </p:txBody>
       </p:sp>
@@ -15973,6 +16145,7 @@
           <a:lstStyle/>
           <a:p>
             <a:pPr algn="ctr"/>
+            <a:endParaRPr/>
           </a:p>
         </p:txBody>
       </p:sp>
@@ -16147,6 +16320,7 @@
           <a:lstStyle/>
           <a:p>
             <a:pPr algn="ctr"/>
+            <a:endParaRPr/>
           </a:p>
         </p:txBody>
       </p:sp>

</xml_diff>